<commit_message>
new file:   UC2026_BCIT.pptx 	modified:   UC2026_simlabs_draft.pptx 	modified:   UC2026_template.pptx
</commit_message>
<xml_diff>
--- a/UC2026_simlabs_draft.pptx
+++ b/UC2026_simlabs_draft.pptx
@@ -4578,7 +4578,7 @@
           <a:p>
             <a:r>
               <a:rPr lang="en-CA" dirty="0"/>
-              <a:t>26.10.2026 - 29.10.2026</a:t>
+              <a:t>26.10.2026 — 29.10.2026</a:t>
             </a:r>
             <a:br>
               <a:rPr lang="en-CA" dirty="0"/>
@@ -4614,7 +4614,7 @@
       </p:grpSpPr>
       <p:sp>
         <p:nvSpPr>
-          <p:cNvPr id="4" name="TextBox 3"/>
+          <p:cNvPr id="4" name="Content Placeholder 3"/>
           <p:cNvSpPr txBox="1">
             <a:spLocks noGrp="1"/>
           </p:cNvSpPr>
@@ -4991,7 +4991,7 @@
       </p:grpSpPr>
       <p:sp>
         <p:nvSpPr>
-          <p:cNvPr id="4" name="TextBox 3"/>
+          <p:cNvPr id="4" name="Content Placeholder 3"/>
           <p:cNvSpPr txBox="1">
             <a:spLocks noGrp="1"/>
           </p:cNvSpPr>
@@ -6878,8 +6878,8 @@
           <a:chExt cx="0" cy="0"/>
         </a:xfrm>
       </p:grpSpPr>
-      <mc:AlternateContent xmlns:mc="http://schemas.openxmlformats.org/markup-compatibility/2006">
-        <mc:Choice xmlns:a14="http://schemas.microsoft.com/office/drawing/2010/main" Requires="a14">
+      <mc:AlternateContent xmlns:mc="http://schemas.openxmlformats.org/markup-compatibility/2006" xmlns:a14="http://schemas.microsoft.com/office/drawing/2010/main">
+        <mc:Choice Requires="a14">
           <p:sp>
             <p:nvSpPr>
               <p:cNvPr id="3" name="Content Placeholder 2"/>
@@ -6926,7 +6926,7 @@
                       <m:sSub>
                         <m:sSubPr>
                           <m:ctrlPr>
-                            <a:rPr>
+                            <a:rPr i="1">
                               <a:latin typeface="Cambria Math" panose="02040503050406030204" pitchFamily="18" charset="0"/>
                             </a:rPr>
                           </m:ctrlPr>
@@ -7114,7 +7114,7 @@
             </p:txBody>
           </p:sp>
         </mc:Choice>
-        <mc:Fallback>
+        <mc:Fallback xmlns="">
           <p:sp>
             <p:nvSpPr>
               <p:cNvPr id="3" name="Content Placeholder 2"/>
@@ -7201,7 +7201,7 @@
       </p:grpSpPr>
       <p:sp>
         <p:nvSpPr>
-          <p:cNvPr id="4" name="TextBox 3"/>
+          <p:cNvPr id="4" name="Content Placeholder 3"/>
           <p:cNvSpPr txBox="1">
             <a:spLocks noGrp="1"/>
           </p:cNvSpPr>
@@ -7306,7 +7306,7 @@
       </p:grpSpPr>
       <p:sp>
         <p:nvSpPr>
-          <p:cNvPr id="4" name="TextBox 3"/>
+          <p:cNvPr id="4" name="Content Placeholder 3"/>
           <p:cNvSpPr txBox="1">
             <a:spLocks noGrp="1"/>
           </p:cNvSpPr>
@@ -7498,7 +7498,7 @@
       </p:grpSpPr>
       <p:sp>
         <p:nvSpPr>
-          <p:cNvPr id="4" name="TextBox 3"/>
+          <p:cNvPr id="4" name="Content Placeholder 3"/>
           <p:cNvSpPr txBox="1">
             <a:spLocks noGrp="1"/>
           </p:cNvSpPr>
@@ -8757,8 +8757,8 @@
           <a:chExt cx="0" cy="0"/>
         </a:xfrm>
       </p:grpSpPr>
-      <mc:AlternateContent xmlns:mc="http://schemas.openxmlformats.org/markup-compatibility/2006">
-        <mc:Choice xmlns:a14="http://schemas.microsoft.com/office/drawing/2010/main" Requires="a14">
+      <mc:AlternateContent xmlns:mc="http://schemas.openxmlformats.org/markup-compatibility/2006" xmlns:a14="http://schemas.microsoft.com/office/drawing/2010/main">
+        <mc:Choice Requires="a14">
           <p:sp>
             <p:nvSpPr>
               <p:cNvPr id="3" name="Content Placeholder 2"/>
@@ -8805,7 +8805,7 @@
                       <m:sSub>
                         <m:sSubPr>
                           <m:ctrlPr>
-                            <a:rPr>
+                            <a:rPr i="1">
                               <a:latin typeface="Cambria Math" panose="02040503050406030204" pitchFamily="18" charset="0"/>
                             </a:rPr>
                           </m:ctrlPr>
@@ -8939,7 +8939,7 @@
             </p:txBody>
           </p:sp>
         </mc:Choice>
-        <mc:Fallback>
+        <mc:Fallback xmlns="">
           <p:sp>
             <p:nvSpPr>
               <p:cNvPr id="3" name="Content Placeholder 2"/>
@@ -9024,8 +9024,8 @@
           <a:chExt cx="0" cy="0"/>
         </a:xfrm>
       </p:grpSpPr>
-      <mc:AlternateContent xmlns:mc="http://schemas.openxmlformats.org/markup-compatibility/2006">
-        <mc:Choice xmlns:a14="http://schemas.microsoft.com/office/drawing/2010/main" Requires="a14">
+      <mc:AlternateContent xmlns:mc="http://schemas.openxmlformats.org/markup-compatibility/2006" xmlns:a14="http://schemas.microsoft.com/office/drawing/2010/main">
+        <mc:Choice Requires="a14">
           <p:sp>
             <p:nvSpPr>
               <p:cNvPr id="3" name="Content Placeholder 2"/>
@@ -9065,7 +9065,7 @@
                       <m:sSub>
                         <m:sSubPr>
                           <m:ctrlPr>
-                            <a:rPr>
+                            <a:rPr i="1">
                               <a:latin typeface="Cambria Math" panose="02040503050406030204" pitchFamily="18" charset="0"/>
                             </a:rPr>
                           </m:ctrlPr>
@@ -9277,7 +9277,7 @@
             </p:txBody>
           </p:sp>
         </mc:Choice>
-        <mc:Fallback>
+        <mc:Fallback xmlns="">
           <p:sp>
             <p:nvSpPr>
               <p:cNvPr id="3" name="Content Placeholder 2"/>
@@ -9681,7 +9681,7 @@
       </p:grpSpPr>
       <p:sp>
         <p:nvSpPr>
-          <p:cNvPr id="4" name="TextBox 3"/>
+          <p:cNvPr id="4" name="Content Placeholder 3"/>
           <p:cNvSpPr txBox="1">
             <a:spLocks noGrp="1"/>
           </p:cNvSpPr>
@@ -9793,7 +9793,7 @@
       </p:grpSpPr>
       <p:sp>
         <p:nvSpPr>
-          <p:cNvPr id="4" name="TextBox 3"/>
+          <p:cNvPr id="4" name="Content Placeholder 3"/>
           <p:cNvSpPr txBox="1">
             <a:spLocks noGrp="1"/>
           </p:cNvSpPr>
@@ -10671,8 +10671,8 @@
           <a:chExt cx="0" cy="0"/>
         </a:xfrm>
       </p:grpSpPr>
-      <mc:AlternateContent xmlns:mc="http://schemas.openxmlformats.org/markup-compatibility/2006">
-        <mc:Choice xmlns:a14="http://schemas.microsoft.com/office/drawing/2010/main" Requires="a14">
+      <mc:AlternateContent xmlns:mc="http://schemas.openxmlformats.org/markup-compatibility/2006" xmlns:a14="http://schemas.microsoft.com/office/drawing/2010/main">
+        <mc:Choice Requires="a14">
           <p:sp>
             <p:nvSpPr>
               <p:cNvPr id="3" name="Content Placeholder 2"/>
@@ -10713,7 +10713,7 @@
                     <m:sSub>
                       <m:sSubPr>
                         <m:ctrlPr>
-                          <a:rPr>
+                          <a:rPr i="1">
                             <a:latin typeface="Cambria Math" panose="02040503050406030204" pitchFamily="18" charset="0"/>
                           </a:rPr>
                         </m:ctrlPr>
@@ -10892,7 +10892,7 @@
             </p:txBody>
           </p:sp>
         </mc:Choice>
-        <mc:Fallback>
+        <mc:Fallback xmlns="">
           <p:sp>
             <p:nvSpPr>
               <p:cNvPr id="3" name="Content Placeholder 2"/>
@@ -12258,11 +12258,16 @@
 <file path=customXml/itemProps2.xml><?xml version="1.0" encoding="utf-8"?>
 <ds:datastoreItem xmlns:ds="http://schemas.openxmlformats.org/officeDocument/2006/customXml" ds:itemID="{7B6F2769-7194-4217-93D3-3AF3A4742282}">
   <ds:schemaRefs>
+    <ds:schemaRef ds:uri="http://purl.org/dc/terms/"/>
+    <ds:schemaRef ds:uri="http://purl.org/dc/elements/1.1/"/>
+    <ds:schemaRef ds:uri="http://schemas.openxmlformats.org/package/2006/metadata/core-properties"/>
+    <ds:schemaRef ds:uri="92b78b11-5582-4f0d-9ede-26dc097105ae"/>
+    <ds:schemaRef ds:uri="http://schemas.microsoft.com/office/2006/documentManagement/types"/>
+    <ds:schemaRef ds:uri="http://schemas.microsoft.com/office/infopath/2007/PartnerControls"/>
     <ds:schemaRef ds:uri="http://schemas.microsoft.com/office/2006/metadata/properties"/>
-    <ds:schemaRef ds:uri="http://schemas.microsoft.com/office/infopath/2007/PartnerControls"/>
-    <ds:schemaRef ds:uri="http://schemas.microsoft.com/sharepoint/v3/fields"/>
-    <ds:schemaRef ds:uri="92b78b11-5582-4f0d-9ede-26dc097105ae"/>
     <ds:schemaRef ds:uri="4b8b16d9-d63f-485d-9d73-fc963e0128fa"/>
+    <ds:schemaRef ds:uri="http://www.w3.org/XML/1998/namespace"/>
+    <ds:schemaRef ds:uri="http://purl.org/dc/dcmitype/"/>
   </ds:schemaRefs>
 </ds:datastoreItem>
 </file>

</xml_diff>